<commit_message>
Rename Deal Summaries to Deal Screening, add 8 new deal screening decks
Renames the "Deal Summaries" tab/label to "Deal Screening" across the
listing page, detail template, sidebar nav, search index, and reciprocal
links. Adds real screening decks for Kalshi, Together AI, Nous Research,
Commure, Assort Health, Ayar Labs, Warp, and Polymarket (kept distinct
from the existing Polymarket investment memo), plus a V2 refresh of the
Gimlet Labs deck. New backfill-deal-research-decks.mjs script pushes the
metadata into Firestore (local or prod), upserting by companyName so
it's safe to re-run.
</commit_message>
<xml_diff>
--- a/hub-next/public/research/Gimlet_Labs_Deal_Draft.pptx
+++ b/hub-next/public/research/Gimlet_Labs_Deal_Draft.pptx
@@ -210,7 +210,7 @@
           <a:p>
             <a:fld id="{0301B205-89CD-41EB-8602-93345E461546}" type="datetimeFigureOut">
               <a:rPr lang="en-US" smtClean="0"/>
-              <a:t>6/19/26</a:t>
+              <a:t>7/1/26</a:t>
             </a:fld>
             <a:endParaRPr lang="en-US"/>
           </a:p>
@@ -824,7 +824,7 @@
           <a:p>
             <a:fld id="{5BCAD085-E8A6-8845-BD4E-CB4CCA059FC4}" type="datetimeFigureOut">
               <a:rPr lang="en-US" smtClean="0"/>
-              <a:t>6/19/26</a:t>
+              <a:t>7/1/26</a:t>
             </a:fld>
             <a:endParaRPr lang="en-US"/>
           </a:p>
@@ -992,7 +992,7 @@
           <a:p>
             <a:fld id="{5BCAD085-E8A6-8845-BD4E-CB4CCA059FC4}" type="datetimeFigureOut">
               <a:rPr lang="en-US" smtClean="0"/>
-              <a:t>6/19/26</a:t>
+              <a:t>7/1/26</a:t>
             </a:fld>
             <a:endParaRPr lang="en-US"/>
           </a:p>
@@ -1170,7 +1170,7 @@
           <a:p>
             <a:fld id="{5BCAD085-E8A6-8845-BD4E-CB4CCA059FC4}" type="datetimeFigureOut">
               <a:rPr lang="en-US" smtClean="0"/>
-              <a:t>6/19/26</a:t>
+              <a:t>7/1/26</a:t>
             </a:fld>
             <a:endParaRPr lang="en-US"/>
           </a:p>
@@ -1338,7 +1338,7 @@
           <a:p>
             <a:fld id="{5BCAD085-E8A6-8845-BD4E-CB4CCA059FC4}" type="datetimeFigureOut">
               <a:rPr lang="en-US" smtClean="0"/>
-              <a:t>6/19/26</a:t>
+              <a:t>7/1/26</a:t>
             </a:fld>
             <a:endParaRPr lang="en-US"/>
           </a:p>
@@ -1583,7 +1583,7 @@
           <a:p>
             <a:fld id="{5BCAD085-E8A6-8845-BD4E-CB4CCA059FC4}" type="datetimeFigureOut">
               <a:rPr lang="en-US" smtClean="0"/>
-              <a:t>6/19/26</a:t>
+              <a:t>7/1/26</a:t>
             </a:fld>
             <a:endParaRPr lang="en-US"/>
           </a:p>
@@ -1868,7 +1868,7 @@
           <a:p>
             <a:fld id="{5BCAD085-E8A6-8845-BD4E-CB4CCA059FC4}" type="datetimeFigureOut">
               <a:rPr lang="en-US" smtClean="0"/>
-              <a:t>6/19/26</a:t>
+              <a:t>7/1/26</a:t>
             </a:fld>
             <a:endParaRPr lang="en-US"/>
           </a:p>
@@ -2287,7 +2287,7 @@
           <a:p>
             <a:fld id="{5BCAD085-E8A6-8845-BD4E-CB4CCA059FC4}" type="datetimeFigureOut">
               <a:rPr lang="en-US" smtClean="0"/>
-              <a:t>6/19/26</a:t>
+              <a:t>7/1/26</a:t>
             </a:fld>
             <a:endParaRPr lang="en-US"/>
           </a:p>
@@ -2404,7 +2404,7 @@
           <a:p>
             <a:fld id="{5BCAD085-E8A6-8845-BD4E-CB4CCA059FC4}" type="datetimeFigureOut">
               <a:rPr lang="en-US" smtClean="0"/>
-              <a:t>6/19/26</a:t>
+              <a:t>7/1/26</a:t>
             </a:fld>
             <a:endParaRPr lang="en-US"/>
           </a:p>
@@ -2499,7 +2499,7 @@
           <a:p>
             <a:fld id="{5BCAD085-E8A6-8845-BD4E-CB4CCA059FC4}" type="datetimeFigureOut">
               <a:rPr lang="en-US" smtClean="0"/>
-              <a:t>6/19/26</a:t>
+              <a:t>7/1/26</a:t>
             </a:fld>
             <a:endParaRPr lang="en-US"/>
           </a:p>
@@ -2774,7 +2774,7 @@
           <a:p>
             <a:fld id="{5BCAD085-E8A6-8845-BD4E-CB4CCA059FC4}" type="datetimeFigureOut">
               <a:rPr lang="en-US" smtClean="0"/>
-              <a:t>6/19/26</a:t>
+              <a:t>7/1/26</a:t>
             </a:fld>
             <a:endParaRPr lang="en-US"/>
           </a:p>
@@ -3026,7 +3026,7 @@
           <a:p>
             <a:fld id="{5BCAD085-E8A6-8845-BD4E-CB4CCA059FC4}" type="datetimeFigureOut">
               <a:rPr lang="en-US" smtClean="0"/>
-              <a:t>6/19/26</a:t>
+              <a:t>7/1/26</a:t>
             </a:fld>
             <a:endParaRPr lang="en-US"/>
           </a:p>
@@ -3237,7 +3237,7 @@
           <a:p>
             <a:fld id="{5BCAD085-E8A6-8845-BD4E-CB4CCA059FC4}" type="datetimeFigureOut">
               <a:rPr lang="en-US" smtClean="0"/>
-              <a:t>6/19/26</a:t>
+              <a:t>7/1/26</a:t>
             </a:fld>
             <a:endParaRPr lang="en-US"/>
           </a:p>
@@ -6820,7 +6820,7 @@
           <p:nvPr>
             <p:extLst>
               <p:ext uri="{D42A27DB-BD31-4B8C-83A1-F6EECF244321}">
-                <p14:modId xmlns:p14="http://schemas.microsoft.com/office/powerpoint/2010/main" val="1015901892"/>
+                <p14:modId xmlns:p14="http://schemas.microsoft.com/office/powerpoint/2010/main" val="3640292002"/>
               </p:ext>
             </p:extLst>
           </p:nvPr>
@@ -6941,7 +6941,7 @@
                           </a:solidFill>
                           <a:latin typeface="Calibri"/>
                         </a:rPr>
-                        <a:t>2</a:t>
+                        <a:t>3 </a:t>
                       </a:r>
                       <a:r>
                         <a:rPr sz="760" b="0" dirty="0">
@@ -7060,13 +7060,22 @@
                     <a:p>
                       <a:pPr algn="r"/>
                       <a:r>
-                        <a:rPr sz="760" b="0">
+                        <a:rPr lang="en-US" sz="760" b="0" dirty="0">
                           <a:solidFill>
                             <a:srgbClr val="1A1A1A"/>
                           </a:solidFill>
                           <a:latin typeface="Calibri"/>
                         </a:rPr>
-                        <a:t>2 / 4</a:t>
+                        <a:t>3</a:t>
+                      </a:r>
+                      <a:r>
+                        <a:rPr sz="760" b="0" dirty="0">
+                          <a:solidFill>
+                            <a:srgbClr val="1A1A1A"/>
+                          </a:solidFill>
+                          <a:latin typeface="Calibri"/>
+                        </a:rPr>
+                        <a:t> / 4</a:t>
                       </a:r>
                     </a:p>
                   </a:txBody>
@@ -7175,7 +7184,7 @@
                           </a:solidFill>
                           <a:latin typeface="Calibri"/>
                         </a:rPr>
-                        <a:t>2.6</a:t>
+                        <a:t>3.0</a:t>
                       </a:r>
                       <a:r>
                         <a:rPr sz="760" b="1" dirty="0">

</xml_diff>